<commit_message>
updates to syncronize README.md and PPTX/PDF/Keynote documentation
</commit_message>
<xml_diff>
--- a/PUFC_V1_Design.pptx
+++ b/PUFC_V1_Design.pptx
@@ -13,6 +13,7 @@
     <p:sldId id="258" r:id="rId10"/>
     <p:sldId id="259" r:id="rId11"/>
     <p:sldId id="260" r:id="rId12"/>
+    <p:sldId id="261" r:id="rId13"/>
   </p:sldIdLst>
   <p:sldSz cx="24384000" cy="13716000"/>
   <p:notesSz cx="6858000" cy="9144000"/>
@@ -4900,6 +4901,105 @@
 </p:sld>
 </file>
 
+<file path=ppt/slides/slide6.xml><?xml version="1.0" encoding="utf-8"?>
+<p:sld xmlns:a="http://schemas.openxmlformats.org/drawingml/2006/main" xmlns:r="http://schemas.openxmlformats.org/officeDocument/2006/relationships" xmlns:p="http://schemas.openxmlformats.org/presentationml/2006/main" xmlns:m="http://schemas.openxmlformats.org/officeDocument/2006/math" xmlns:a14="http://schemas.microsoft.com/office/drawing/2010/main" showMasterSp="1" showMasterPhAnim="1">
+  <p:cSld>
+    <p:spTree>
+      <p:nvGrpSpPr>
+        <p:cNvPr id="1" name=""/>
+        <p:cNvGrpSpPr/>
+        <p:nvPr/>
+      </p:nvGrpSpPr>
+      <p:grpSpPr>
+        <a:xfrm>
+          <a:off x="0" y="0"/>
+          <a:ext cx="0" cy="0"/>
+          <a:chOff x="0" y="0"/>
+          <a:chExt cx="0" cy="0"/>
+        </a:xfrm>
+      </p:grpSpPr>
+      <p:sp>
+        <p:nvSpPr>
+          <p:cNvPr id="163" name="Additional TODOs…"/>
+          <p:cNvSpPr txBox="1"/>
+          <p:nvPr>
+            <p:ph type="title"/>
+          </p:nvPr>
+        </p:nvSpPr>
+        <p:spPr>
+          <a:xfrm>
+            <a:off x="1206496" y="1225494"/>
+            <a:ext cx="21971004" cy="11380447"/>
+          </a:xfrm>
+          <a:prstGeom prst="rect">
+            <a:avLst/>
+          </a:prstGeom>
+        </p:spPr>
+        <p:txBody>
+          <a:bodyPr/>
+          <a:lstStyle/>
+          <a:p>
+            <a:pPr/>
+            <a:r>
+              <a:t>Additional TODOs</a:t>
+            </a:r>
+          </a:p>
+          <a:p>
+            <a:pPr lvl="2" marL="2667000" indent="-889000">
+              <a:lnSpc>
+                <a:spcPct val="90000"/>
+              </a:lnSpc>
+              <a:spcBef>
+                <a:spcPts val="4500"/>
+              </a:spcBef>
+              <a:buSzPct val="100000"/>
+              <a:defRPr b="0" spc="0" sz="4800"/>
+            </a:pPr>
+            <a:r>
+              <a:t>(1) Test Google spreadsheet lookup that integrates with Google workspace documentation for club's referee listing.  This is where we plan to centralize and secure referee information for week-to-week planning</a:t>
+            </a:r>
+          </a:p>
+          <a:p>
+            <a:pPr lvl="2" marL="2667000" indent="-889000">
+              <a:lnSpc>
+                <a:spcPct val="90000"/>
+              </a:lnSpc>
+              <a:spcBef>
+                <a:spcPts val="4500"/>
+              </a:spcBef>
+              <a:buSzPct val="100000"/>
+              <a:defRPr b="0" spc="0" sz="4800"/>
+            </a:pPr>
+            <a:r>
+              <a:t>Build and test API connectivity to AdminSports</a:t>
+            </a:r>
+          </a:p>
+          <a:p>
+            <a:pPr lvl="2" marL="2667000" indent="-889000">
+              <a:lnSpc>
+                <a:spcPct val="90000"/>
+              </a:lnSpc>
+              <a:spcBef>
+                <a:spcPts val="4500"/>
+              </a:spcBef>
+              <a:buSzPct val="100000"/>
+              <a:defRPr b="0" spc="0" sz="4800"/>
+            </a:pPr>
+            <a:r>
+              <a:t>Implement the desired logic as a separate look-up to ensure modularity</a:t>
+            </a:r>
+          </a:p>
+        </p:txBody>
+      </p:sp>
+    </p:spTree>
+  </p:cSld>
+  <p:clrMapOvr>
+    <a:masterClrMapping/>
+  </p:clrMapOvr>
+  <p:transition xmlns:p14="http://schemas.microsoft.com/office/powerpoint/2010/main" spd="med" advClick="1"/>
+</p:sld>
+</file>
+
 <file path=ppt/theme/theme1.xml><?xml version="1.0" encoding="utf-8"?>
 <a:theme xmlns:a="http://schemas.openxmlformats.org/drawingml/2006/main" xmlns:r="http://schemas.openxmlformats.org/officeDocument/2006/relationships" name="32_DynamicDark">
   <a:themeElements>

</xml_diff>